<commit_message>
update the hydro and curtailment files
</commit_message>
<xml_diff>
--- a/quality_reports/decks/2026-03-03_Benchmarking_Update_PCM_vs_Paper.pptx
+++ b/quality_reports/decks/2026-03-03_Benchmarking_Update_PCM_vs_Paper.pptx
@@ -20,6 +20,9 @@
     <p:sldId id="269" r:id="rId11"/>
     <p:sldId id="261" r:id="rId12"/>
     <p:sldId id="263" r:id="rId13"/>
+    <p:sldId id="270" r:id="rId19"/>
+    <p:sldId id="271" r:id="rId20"/>
+    <p:sldId id="272" r:id="rId21"/>
   </p:sldIdLst>
   <p:sldSz cx="12192000" cy="6858000"/>
   <p:notesSz cx="6858000" cy="9144000"/>
@@ -561,6 +564,81 @@
         </p:nvSpPr>
         <p:spPr/>
       </p:sp>
+    </p:spTree>
+  </p:cSld>
+  <p:clrMapOvr>
+    <a:masterClrMapping/>
+  </p:clrMapOvr>
+</p:notes>
+</file>
+
+<file path=ppt/notesSlides/notesSlide13.xml><?xml version="1.0" encoding="utf-8"?>
+<p:notes xmlns:a="http://schemas.openxmlformats.org/drawingml/2006/main" xmlns:p="http://schemas.openxmlformats.org/presentationml/2006/main" xmlns:r="http://schemas.openxmlformats.org/officeDocument/2006/relationships">
+  <p:cSld>
+    <p:spTree>
+      <p:nvGrpSpPr>
+        <p:cNvPr id="1" name=""/>
+        <p:cNvGrpSpPr/>
+        <p:nvPr/>
+      </p:nvGrpSpPr>
+      <p:grpSpPr>
+        <a:xfrm>
+          <a:off x="0" y="0"/>
+          <a:ext cx="0" cy="0"/>
+          <a:chOff x="0" y="0"/>
+          <a:chExt cx="0" cy="0"/>
+        </a:xfrm>
+      </p:grpSpPr>
+    </p:spTree>
+  </p:cSld>
+  <p:clrMapOvr>
+    <a:masterClrMapping/>
+  </p:clrMapOvr>
+</p:notes>
+</file>
+
+<file path=ppt/notesSlides/notesSlide14.xml><?xml version="1.0" encoding="utf-8"?>
+<p:notes xmlns:a="http://schemas.openxmlformats.org/drawingml/2006/main" xmlns:p="http://schemas.openxmlformats.org/presentationml/2006/main" xmlns:r="http://schemas.openxmlformats.org/officeDocument/2006/relationships">
+  <p:cSld>
+    <p:spTree>
+      <p:nvGrpSpPr>
+        <p:cNvPr id="1" name=""/>
+        <p:cNvGrpSpPr/>
+        <p:nvPr/>
+      </p:nvGrpSpPr>
+      <p:grpSpPr>
+        <a:xfrm>
+          <a:off x="0" y="0"/>
+          <a:ext cx="0" cy="0"/>
+          <a:chOff x="0" y="0"/>
+          <a:chExt cx="0" cy="0"/>
+        </a:xfrm>
+      </p:grpSpPr>
+    </p:spTree>
+  </p:cSld>
+  <p:clrMapOvr>
+    <a:masterClrMapping/>
+  </p:clrMapOvr>
+</p:notes>
+</file>
+
+<file path=ppt/notesSlides/notesSlide15.xml><?xml version="1.0" encoding="utf-8"?>
+<p:notes xmlns:a="http://schemas.openxmlformats.org/drawingml/2006/main" xmlns:p="http://schemas.openxmlformats.org/presentationml/2006/main" xmlns:r="http://schemas.openxmlformats.org/officeDocument/2006/relationships">
+  <p:cSld>
+    <p:spTree>
+      <p:nvGrpSpPr>
+        <p:cNvPr id="1" name=""/>
+        <p:cNvGrpSpPr/>
+        <p:nvPr/>
+      </p:nvGrpSpPr>
+      <p:grpSpPr>
+        <a:xfrm>
+          <a:off x="0" y="0"/>
+          <a:ext cx="0" cy="0"/>
+          <a:chOff x="0" y="0"/>
+          <a:chExt cx="0" cy="0"/>
+        </a:xfrm>
+      </p:grpSpPr>
     </p:spTree>
   </p:cSld>
   <p:clrMapOvr>
@@ -6063,6 +6141,1703 @@
                 </a:solidFill>
               </a:rPr>
               <a:t>success criteria as sign/trend alignment first, magnitude second.</a:t>
+            </a:r>
+          </a:p>
+        </p:txBody>
+      </p:sp>
+    </p:spTree>
+  </p:cSld>
+  <p:clrMapOvr>
+    <a:masterClrMapping/>
+  </p:clrMapOvr>
+</p:sld>
+</file>
+
+<file path=ppt/slides/slide13.xml><?xml version="1.0" encoding="utf-8"?>
+<p:sld xmlns:a="http://schemas.openxmlformats.org/drawingml/2006/main" xmlns:p="http://schemas.openxmlformats.org/presentationml/2006/main" xmlns:r="http://schemas.openxmlformats.org/officeDocument/2006/relationships">
+  <p:cSld>
+    <p:bg>
+      <p:bgPr>
+        <a:solidFill>
+          <a:srgbClr val="FFFFFF"/>
+        </a:solidFill>
+        <a:effectLst/>
+      </p:bgPr>
+    </p:bg>
+    <p:spTree>
+      <p:nvGrpSpPr>
+        <p:cNvPr id="1" name=""/>
+        <p:cNvGrpSpPr/>
+        <p:nvPr/>
+      </p:nvGrpSpPr>
+      <p:grpSpPr/>
+      <p:sp>
+        <p:nvSpPr>
+          <p:cNvPr id="2" name="Rectangle 1"/>
+          <p:cNvSpPr/>
+          <p:nvPr/>
+        </p:nvSpPr>
+        <p:spPr>
+          <a:xfrm>
+            <a:off x="0" y="0"/>
+            <a:ext cx="12191695" cy="1097280"/>
+          </a:xfrm>
+          <a:prstGeom prst="rect">
+            <a:avLst/>
+          </a:prstGeom>
+          <a:solidFill>
+            <a:srgbClr val="1B3A5C"/>
+          </a:solidFill>
+          <a:ln>
+            <a:noFill/>
+          </a:ln>
+        </p:spPr>
+        <p:style>
+          <a:lnRef idx="1">
+            <a:schemeClr val="accent1"/>
+          </a:lnRef>
+          <a:fillRef idx="3">
+            <a:schemeClr val="accent1"/>
+          </a:fillRef>
+          <a:effectRef idx="2">
+            <a:schemeClr val="accent1"/>
+          </a:effectRef>
+          <a:fontRef idx="minor">
+            <a:schemeClr val="lt1"/>
+          </a:fontRef>
+        </p:style>
+        <p:txBody>
+          <a:bodyPr rtlCol="0" anchor="ctr" wrap="square" lIns="548640"/>
+          <a:lstStyle/>
+          <a:p>
+            <a:pPr algn="l">
+              <a:defRPr sz="3000" b="1">
+                <a:solidFill>
+                  <a:srgbClr val="FFFFFF"/>
+                </a:solidFill>
+              </a:defRPr>
+            </a:pPr>
+            <a:r>
+              <a:t>How Curtailment Is Realized in Our Prescient Pipeline</a:t>
+            </a:r>
+          </a:p>
+        </p:txBody>
+      </p:sp>
+      <p:sp>
+        <p:nvSpPr>
+          <p:cNvPr id="3" name="Rectangle 2"/>
+          <p:cNvSpPr/>
+          <p:nvPr/>
+        </p:nvSpPr>
+        <p:spPr>
+          <a:xfrm>
+            <a:off x="0" y="1097280"/>
+            <a:ext cx="12191695" cy="411480"/>
+          </a:xfrm>
+          <a:prstGeom prst="rect">
+            <a:avLst/>
+          </a:prstGeom>
+          <a:solidFill>
+            <a:srgbClr val="2C5F8A"/>
+          </a:solidFill>
+          <a:ln>
+            <a:noFill/>
+          </a:ln>
+        </p:spPr>
+        <p:style>
+          <a:lnRef idx="1">
+            <a:schemeClr val="accent1"/>
+          </a:lnRef>
+          <a:fillRef idx="3">
+            <a:schemeClr val="accent1"/>
+          </a:fillRef>
+          <a:effectRef idx="2">
+            <a:schemeClr val="accent1"/>
+          </a:effectRef>
+          <a:fontRef idx="minor">
+            <a:schemeClr val="lt1"/>
+          </a:fontRef>
+        </p:style>
+        <p:txBody>
+          <a:bodyPr rtlCol="0" anchor="ctr" lIns="548640"/>
+          <a:lstStyle/>
+          <a:p>
+            <a:pPr algn="l">
+              <a:defRPr sz="1500" i="1">
+                <a:solidFill>
+                  <a:srgbClr val="CCDDEE"/>
+                </a:solidFill>
+              </a:defRPr>
+            </a:pPr>
+            <a:r>
+              <a:t>Proxy mechanism via SCED/RUC penalty-threshold economics</a:t>
+            </a:r>
+          </a:p>
+        </p:txBody>
+      </p:sp>
+      <p:sp>
+        <p:nvSpPr>
+          <p:cNvPr id="4" name="TextBox 3"/>
+          <p:cNvSpPr txBox="1"/>
+          <p:nvPr/>
+        </p:nvSpPr>
+        <p:spPr>
+          <a:xfrm>
+            <a:off x="640080" y="1874520"/>
+            <a:ext cx="10972800" cy="4389120"/>
+          </a:xfrm>
+          <a:prstGeom prst="rect">
+            <a:avLst/>
+          </a:prstGeom>
+          <a:noFill/>
+        </p:spPr>
+        <p:txBody>
+          <a:bodyPr wrap="square">
+            <a:spAutoFit/>
+          </a:bodyPr>
+          <a:lstStyle/>
+          <a:p>
+            <a:pPr>
+              <a:spcAft>
+                <a:spcPts val="500"/>
+              </a:spcAft>
+            </a:pPr>
+            <a:r>
+              <a:rPr sz="1600" b="1">
+                <a:solidFill>
+                  <a:srgbClr val="333333"/>
+                </a:solidFill>
+              </a:rPr>
+              <a:t>No standalone 'renewable curtailment penalty' switch in current Prescient run configuration.</a:t>
+            </a:r>
+          </a:p>
+          <a:p>
+            <a:pPr>
+              <a:spcAft>
+                <a:spcPts val="500"/>
+              </a:spcAft>
+            </a:pPr>
+            <a:r>
+              <a:rPr sz="1600" b="0">
+                <a:solidFill>
+                  <a:srgbClr val="333333"/>
+                </a:solidFill>
+              </a:rPr>
+              <a:t>We tune price/violation thresholds to shape dispatch and curtailment outcomes.</a:t>
+            </a:r>
+          </a:p>
+          <a:p>
+            <a:pPr>
+              <a:spcAft>
+                <a:spcPts val="500"/>
+              </a:spcAft>
+            </a:pPr>
+            <a:r>
+              <a:rPr sz="1600" b="1">
+                <a:solidFill>
+                  <a:srgbClr val="333333"/>
+                </a:solidFill>
+              </a:rPr>
+              <a:t>Curtailment is tracked directly in outputs:</a:t>
+            </a:r>
+          </a:p>
+          <a:p>
+            <a:pPr lvl="1">
+              <a:spcAft>
+                <a:spcPts val="500"/>
+              </a:spcAft>
+            </a:pPr>
+            <a:r>
+              <a:rPr sz="1600" b="0">
+                <a:solidFill>
+                  <a:srgbClr val="333333"/>
+                </a:solidFill>
+              </a:rPr>
+              <a:t>renewables_detail.csv -&gt; Curtailment</a:t>
+            </a:r>
+          </a:p>
+          <a:p>
+            <a:pPr lvl="1">
+              <a:spcAft>
+                <a:spcPts val="500"/>
+              </a:spcAft>
+            </a:pPr>
+            <a:r>
+              <a:rPr sz="1600" b="0">
+                <a:solidFill>
+                  <a:srgbClr val="333333"/>
+                </a:solidFill>
+              </a:rPr>
+              <a:t>hourly_summary.csv -&gt; RenewablesCurtailment</a:t>
+            </a:r>
+          </a:p>
+          <a:p>
+            <a:pPr>
+              <a:spcAft>
+                <a:spcPts val="500"/>
+              </a:spcAft>
+            </a:pPr>
+            <a:r>
+              <a:rPr sz="1600" b="1">
+                <a:solidFill>
+                  <a:srgbClr val="333333"/>
+                </a:solidFill>
+              </a:rPr>
+              <a:t>Sweep cases: 300 / 1000 / 2000 / 5000 / 10000 $/MWh.</a:t>
+            </a:r>
+          </a:p>
+          <a:p>
+            <a:pPr>
+              <a:spcAft>
+                <a:spcPts val="500"/>
+              </a:spcAft>
+            </a:pPr>
+            <a:r>
+              <a:rPr sz="1600" b="0">
+                <a:solidFill>
+                  <a:srgbClr val="333333"/>
+                </a:solidFill>
+              </a:rPr>
+              <a:t>Interpretation caution: this is a curtailment-penalty proxy, not a one-parameter physical curtailment model.</a:t>
+            </a:r>
+          </a:p>
+        </p:txBody>
+      </p:sp>
+    </p:spTree>
+  </p:cSld>
+  <p:clrMapOvr>
+    <a:masterClrMapping/>
+  </p:clrMapOvr>
+</p:sld>
+</file>
+
+<file path=ppt/slides/slide14.xml><?xml version="1.0" encoding="utf-8"?>
+<p:sld xmlns:a="http://schemas.openxmlformats.org/drawingml/2006/main" xmlns:p="http://schemas.openxmlformats.org/presentationml/2006/main" xmlns:r="http://schemas.openxmlformats.org/officeDocument/2006/relationships">
+  <p:cSld>
+    <p:bg>
+      <p:bgPr>
+        <a:solidFill>
+          <a:srgbClr val="FFFFFF"/>
+        </a:solidFill>
+        <a:effectLst/>
+      </p:bgPr>
+    </p:bg>
+    <p:spTree>
+      <p:nvGrpSpPr>
+        <p:cNvPr id="1" name=""/>
+        <p:cNvGrpSpPr/>
+        <p:nvPr/>
+      </p:nvGrpSpPr>
+      <p:grpSpPr/>
+      <p:sp>
+        <p:nvSpPr>
+          <p:cNvPr id="2" name="Rectangle 1"/>
+          <p:cNvSpPr/>
+          <p:nvPr/>
+        </p:nvSpPr>
+        <p:spPr>
+          <a:xfrm>
+            <a:off x="0" y="0"/>
+            <a:ext cx="12191695" cy="1097280"/>
+          </a:xfrm>
+          <a:prstGeom prst="rect">
+            <a:avLst/>
+          </a:prstGeom>
+          <a:solidFill>
+            <a:srgbClr val="1B3A5C"/>
+          </a:solidFill>
+          <a:ln>
+            <a:noFill/>
+          </a:ln>
+        </p:spPr>
+        <p:style>
+          <a:lnRef idx="1">
+            <a:schemeClr val="accent1"/>
+          </a:lnRef>
+          <a:fillRef idx="3">
+            <a:schemeClr val="accent1"/>
+          </a:fillRef>
+          <a:effectRef idx="2">
+            <a:schemeClr val="accent1"/>
+          </a:effectRef>
+          <a:fontRef idx="minor">
+            <a:schemeClr val="lt1"/>
+          </a:fontRef>
+        </p:style>
+        <p:txBody>
+          <a:bodyPr rtlCol="0" anchor="ctr" wrap="square" lIns="548640"/>
+          <a:lstStyle/>
+          <a:p>
+            <a:pPr algn="l">
+              <a:defRPr sz="3000" b="1">
+                <a:solidFill>
+                  <a:srgbClr val="FFFFFF"/>
+                </a:solidFill>
+              </a:defRPr>
+            </a:pPr>
+            <a:r>
+              <a:t>Curtailment Penalty Sweep Results (Jan-Mar Common Window)</a:t>
+            </a:r>
+          </a:p>
+        </p:txBody>
+      </p:sp>
+      <p:sp>
+        <p:nvSpPr>
+          <p:cNvPr id="3" name="Rectangle 2"/>
+          <p:cNvSpPr/>
+          <p:nvPr/>
+        </p:nvSpPr>
+        <p:spPr>
+          <a:xfrm>
+            <a:off x="0" y="1097280"/>
+            <a:ext cx="12191695" cy="411480"/>
+          </a:xfrm>
+          <a:prstGeom prst="rect">
+            <a:avLst/>
+          </a:prstGeom>
+          <a:solidFill>
+            <a:srgbClr val="2C5F8A"/>
+          </a:solidFill>
+          <a:ln>
+            <a:noFill/>
+          </a:ln>
+        </p:spPr>
+        <p:style>
+          <a:lnRef idx="1">
+            <a:schemeClr val="accent1"/>
+          </a:lnRef>
+          <a:fillRef idx="3">
+            <a:schemeClr val="accent1"/>
+          </a:fillRef>
+          <a:effectRef idx="2">
+            <a:schemeClr val="accent1"/>
+          </a:effectRef>
+          <a:fontRef idx="minor">
+            <a:schemeClr val="lt1"/>
+          </a:fontRef>
+        </p:style>
+        <p:txBody>
+          <a:bodyPr rtlCol="0" anchor="ctr" lIns="548640"/>
+          <a:lstStyle/>
+          <a:p>
+            <a:pPr algn="l">
+              <a:defRPr sz="1500" i="1">
+                <a:solidFill>
+                  <a:srgbClr val="CCDDEE"/>
+                </a:solidFill>
+              </a:defRPr>
+            </a:pPr>
+            <a:r>
+              <a:t>Common window: 2019-01-01 00:00 to 2019-03-31 23:00</a:t>
+            </a:r>
+          </a:p>
+        </p:txBody>
+      </p:sp>
+      <p:graphicFrame>
+        <p:nvGraphicFramePr>
+          <p:cNvPr id="4" name="Table 3"/>
+          <p:cNvGraphicFramePr>
+            <a:graphicFrameLocks noGrp="1"/>
+          </p:cNvGraphicFramePr>
+          <p:nvPr/>
+        </p:nvGraphicFramePr>
+        <p:xfrm>
+          <a:off x="457200" y="1920240"/>
+          <a:ext cx="11247120" cy="1920000"/>
+        </p:xfrm>
+        <a:graphic>
+          <a:graphicData uri="http://schemas.openxmlformats.org/drawingml/2006/table">
+            <a:tbl>
+              <a:tblPr firstRow="1" bandRow="1">
+                <a:tableStyleId>{5C22544A-7EE6-4342-B048-85BDC9FD1C3A}</a:tableStyleId>
+              </a:tblPr>
+              <a:tblGrid>
+                <a:gridCol w="1874520"/>
+                <a:gridCol w="1874520"/>
+                <a:gridCol w="1874520"/>
+                <a:gridCol w="1874520"/>
+                <a:gridCol w="1874520"/>
+                <a:gridCol w="1874520"/>
+              </a:tblGrid>
+              <a:tr h="320000">
+                <a:tc>
+                  <a:txBody>
+                    <a:bodyPr/>
+                    <a:lstStyle/>
+                    <a:p>
+                      <a:pPr algn="ctr">
+                        <a:defRPr b="1" sz="1100">
+                          <a:solidFill>
+                            <a:srgbClr val="FFFFFF"/>
+                          </a:solidFill>
+                        </a:defRPr>
+                      </a:pPr>
+                      <a:r>
+                        <a:t>Case</a:t>
+                      </a:r>
+                    </a:p>
+                  </a:txBody>
+                  <a:tcPr anchor="ctr">
+                    <a:solidFill>
+                      <a:srgbClr val="1B3A5C"/>
+                    </a:solidFill>
+                  </a:tcPr>
+                </a:tc>
+                <a:tc>
+                  <a:txBody>
+                    <a:bodyPr/>
+                    <a:lstStyle/>
+                    <a:p>
+                      <a:pPr algn="ctr">
+                        <a:defRPr b="1" sz="1100">
+                          <a:solidFill>
+                            <a:srgbClr val="FFFFFF"/>
+                          </a:solidFill>
+                        </a:defRPr>
+                      </a:pPr>
+                      <a:r>
+                        <a:t>Neg LMP %</a:t>
+                      </a:r>
+                    </a:p>
+                  </a:txBody>
+                  <a:tcPr anchor="ctr">
+                    <a:solidFill>
+                      <a:srgbClr val="1B3A5C"/>
+                    </a:solidFill>
+                  </a:tcPr>
+                </a:tc>
+                <a:tc>
+                  <a:txBody>
+                    <a:bodyPr/>
+                    <a:lstStyle/>
+                    <a:p>
+                      <a:pPr algn="ctr">
+                        <a:defRPr b="1" sz="1100">
+                          <a:solidFill>
+                            <a:srgbClr val="FFFFFF"/>
+                          </a:solidFill>
+                        </a:defRPr>
+                      </a:pPr>
+                      <a:r>
+                        <a:t>Floor-hit %</a:t>
+                      </a:r>
+                    </a:p>
+                  </a:txBody>
+                  <a:tcPr anchor="ctr">
+                    <a:solidFill>
+                      <a:srgbClr val="1B3A5C"/>
+                    </a:solidFill>
+                  </a:tcPr>
+                </a:tc>
+                <a:tc>
+                  <a:txBody>
+                    <a:bodyPr/>
+                    <a:lstStyle/>
+                    <a:p>
+                      <a:pPr algn="ctr">
+                        <a:defRPr b="1" sz="1100">
+                          <a:solidFill>
+                            <a:srgbClr val="FFFFFF"/>
+                          </a:solidFill>
+                        </a:defRPr>
+                      </a:pPr>
+                      <a:r>
+                        <a:t>Weighted LMP</a:t>
+                      </a:r>
+                    </a:p>
+                  </a:txBody>
+                  <a:tcPr anchor="ctr">
+                    <a:solidFill>
+                      <a:srgbClr val="1B3A5C"/>
+                    </a:solidFill>
+                  </a:tcPr>
+                </a:tc>
+                <a:tc>
+                  <a:txBody>
+                    <a:bodyPr/>
+                    <a:lstStyle/>
+                    <a:p>
+                      <a:pPr algn="ctr">
+                        <a:defRPr b="1" sz="1100">
+                          <a:solidFill>
+                            <a:srgbClr val="FFFFFF"/>
+                          </a:solidFill>
+                        </a:defRPr>
+                      </a:pPr>
+                      <a:r>
+                        <a:t>Curtail (MWh)</a:t>
+                      </a:r>
+                    </a:p>
+                  </a:txBody>
+                  <a:tcPr anchor="ctr">
+                    <a:solidFill>
+                      <a:srgbClr val="1B3A5C"/>
+                    </a:solidFill>
+                  </a:tcPr>
+                </a:tc>
+                <a:tc>
+                  <a:txBody>
+                    <a:bodyPr/>
+                    <a:lstStyle/>
+                    <a:p>
+                      <a:pPr algn="ctr">
+                        <a:defRPr b="1" sz="1100">
+                          <a:solidFill>
+                            <a:srgbClr val="FFFFFF"/>
+                          </a:solidFill>
+                        </a:defRPr>
+                      </a:pPr>
+                      <a:r>
+                        <a:t>OverGen (MWh)</a:t>
+                      </a:r>
+                    </a:p>
+                  </a:txBody>
+                  <a:tcPr anchor="ctr">
+                    <a:solidFill>
+                      <a:srgbClr val="1B3A5C"/>
+                    </a:solidFill>
+                  </a:tcPr>
+                </a:tc>
+              </a:tr>
+              <a:tr h="320000">
+                <a:tc>
+                  <a:txBody>
+                    <a:bodyPr/>
+                    <a:lstStyle/>
+                    <a:p>
+                      <a:pPr algn="ctr">
+                        <a:defRPr sz="1100">
+                          <a:solidFill>
+                            <a:srgbClr val="333333"/>
+                          </a:solidFill>
+                        </a:defRPr>
+                      </a:pPr>
+                      <a:r>
+                        <a:t>penalty_300</a:t>
+                      </a:r>
+                    </a:p>
+                  </a:txBody>
+                  <a:tcPr anchor="ctr">
+                    <a:solidFill>
+                      <a:srgbClr val="D6E8F7"/>
+                    </a:solidFill>
+                  </a:tcPr>
+                </a:tc>
+                <a:tc>
+                  <a:txBody>
+                    <a:bodyPr/>
+                    <a:lstStyle/>
+                    <a:p>
+                      <a:pPr algn="ctr">
+                        <a:defRPr sz="1100">
+                          <a:solidFill>
+                            <a:srgbClr val="333333"/>
+                          </a:solidFill>
+                        </a:defRPr>
+                      </a:pPr>
+                      <a:r>
+                        <a:t>9.62%</a:t>
+                      </a:r>
+                    </a:p>
+                  </a:txBody>
+                  <a:tcPr anchor="ctr">
+                    <a:solidFill>
+                      <a:srgbClr val="D6E8F7"/>
+                    </a:solidFill>
+                  </a:tcPr>
+                </a:tc>
+                <a:tc>
+                  <a:txBody>
+                    <a:bodyPr/>
+                    <a:lstStyle/>
+                    <a:p>
+                      <a:pPr algn="ctr">
+                        <a:defRPr sz="1100">
+                          <a:solidFill>
+                            <a:srgbClr val="333333"/>
+                          </a:solidFill>
+                        </a:defRPr>
+                      </a:pPr>
+                      <a:r>
+                        <a:t>1.52%</a:t>
+                      </a:r>
+                    </a:p>
+                  </a:txBody>
+                  <a:tcPr anchor="ctr">
+                    <a:solidFill>
+                      <a:srgbClr val="D6E8F7"/>
+                    </a:solidFill>
+                  </a:tcPr>
+                </a:tc>
+                <a:tc>
+                  <a:txBody>
+                    <a:bodyPr/>
+                    <a:lstStyle/>
+                    <a:p>
+                      <a:pPr algn="ctr">
+                        <a:defRPr sz="1100">
+                          <a:solidFill>
+                            <a:srgbClr val="333333"/>
+                          </a:solidFill>
+                        </a:defRPr>
+                      </a:pPr>
+                      <a:r>
+                        <a:t>9.79</a:t>
+                      </a:r>
+                    </a:p>
+                  </a:txBody>
+                  <a:tcPr anchor="ctr">
+                    <a:solidFill>
+                      <a:srgbClr val="D6E8F7"/>
+                    </a:solidFill>
+                  </a:tcPr>
+                </a:tc>
+                <a:tc>
+                  <a:txBody>
+                    <a:bodyPr/>
+                    <a:lstStyle/>
+                    <a:p>
+                      <a:pPr algn="ctr">
+                        <a:defRPr sz="1100">
+                          <a:solidFill>
+                            <a:srgbClr val="333333"/>
+                          </a:solidFill>
+                        </a:defRPr>
+                      </a:pPr>
+                      <a:r>
+                        <a:t>118,560</a:t>
+                      </a:r>
+                    </a:p>
+                  </a:txBody>
+                  <a:tcPr anchor="ctr">
+                    <a:solidFill>
+                      <a:srgbClr val="D6E8F7"/>
+                    </a:solidFill>
+                  </a:tcPr>
+                </a:tc>
+                <a:tc>
+                  <a:txBody>
+                    <a:bodyPr/>
+                    <a:lstStyle/>
+                    <a:p>
+                      <a:pPr algn="ctr">
+                        <a:defRPr sz="1100">
+                          <a:solidFill>
+                            <a:srgbClr val="333333"/>
+                          </a:solidFill>
+                        </a:defRPr>
+                      </a:pPr>
+                      <a:r>
+                        <a:t>888,328</a:t>
+                      </a:r>
+                    </a:p>
+                  </a:txBody>
+                  <a:tcPr anchor="ctr">
+                    <a:solidFill>
+                      <a:srgbClr val="D6E8F7"/>
+                    </a:solidFill>
+                  </a:tcPr>
+                </a:tc>
+              </a:tr>
+              <a:tr h="320000">
+                <a:tc>
+                  <a:txBody>
+                    <a:bodyPr/>
+                    <a:lstStyle/>
+                    <a:p>
+                      <a:pPr algn="ctr">
+                        <a:defRPr sz="1100">
+                          <a:solidFill>
+                            <a:srgbClr val="333333"/>
+                          </a:solidFill>
+                        </a:defRPr>
+                      </a:pPr>
+                      <a:r>
+                        <a:t>penalty_1000</a:t>
+                      </a:r>
+                    </a:p>
+                  </a:txBody>
+                  <a:tcPr anchor="ctr">
+                    <a:solidFill>
+                      <a:srgbClr val="FFFFFF"/>
+                    </a:solidFill>
+                  </a:tcPr>
+                </a:tc>
+                <a:tc>
+                  <a:txBody>
+                    <a:bodyPr/>
+                    <a:lstStyle/>
+                    <a:p>
+                      <a:pPr algn="ctr">
+                        <a:defRPr sz="1100">
+                          <a:solidFill>
+                            <a:srgbClr val="333333"/>
+                          </a:solidFill>
+                        </a:defRPr>
+                      </a:pPr>
+                      <a:r>
+                        <a:t>10.51%</a:t>
+                      </a:r>
+                    </a:p>
+                  </a:txBody>
+                  <a:tcPr anchor="ctr">
+                    <a:solidFill>
+                      <a:srgbClr val="FFFFFF"/>
+                    </a:solidFill>
+                  </a:tcPr>
+                </a:tc>
+                <a:tc>
+                  <a:txBody>
+                    <a:bodyPr/>
+                    <a:lstStyle/>
+                    <a:p>
+                      <a:pPr algn="ctr">
+                        <a:defRPr sz="1100">
+                          <a:solidFill>
+                            <a:srgbClr val="333333"/>
+                          </a:solidFill>
+                        </a:defRPr>
+                      </a:pPr>
+                      <a:r>
+                        <a:t>1.50%</a:t>
+                      </a:r>
+                    </a:p>
+                  </a:txBody>
+                  <a:tcPr anchor="ctr">
+                    <a:solidFill>
+                      <a:srgbClr val="FFFFFF"/>
+                    </a:solidFill>
+                  </a:tcPr>
+                </a:tc>
+                <a:tc>
+                  <a:txBody>
+                    <a:bodyPr/>
+                    <a:lstStyle/>
+                    <a:p>
+                      <a:pPr algn="ctr">
+                        <a:defRPr sz="1100">
+                          <a:solidFill>
+                            <a:srgbClr val="333333"/>
+                          </a:solidFill>
+                        </a:defRPr>
+                      </a:pPr>
+                      <a:r>
+                        <a:t>3.96</a:t>
+                      </a:r>
+                    </a:p>
+                  </a:txBody>
+                  <a:tcPr anchor="ctr">
+                    <a:solidFill>
+                      <a:srgbClr val="FFFFFF"/>
+                    </a:solidFill>
+                  </a:tcPr>
+                </a:tc>
+                <a:tc>
+                  <a:txBody>
+                    <a:bodyPr/>
+                    <a:lstStyle/>
+                    <a:p>
+                      <a:pPr algn="ctr">
+                        <a:defRPr sz="1100">
+                          <a:solidFill>
+                            <a:srgbClr val="333333"/>
+                          </a:solidFill>
+                        </a:defRPr>
+                      </a:pPr>
+                      <a:r>
+                        <a:t>124,325</a:t>
+                      </a:r>
+                    </a:p>
+                  </a:txBody>
+                  <a:tcPr anchor="ctr">
+                    <a:solidFill>
+                      <a:srgbClr val="FFFFFF"/>
+                    </a:solidFill>
+                  </a:tcPr>
+                </a:tc>
+                <a:tc>
+                  <a:txBody>
+                    <a:bodyPr/>
+                    <a:lstStyle/>
+                    <a:p>
+                      <a:pPr algn="ctr">
+                        <a:defRPr sz="1100">
+                          <a:solidFill>
+                            <a:srgbClr val="333333"/>
+                          </a:solidFill>
+                        </a:defRPr>
+                      </a:pPr>
+                      <a:r>
+                        <a:t>889,003</a:t>
+                      </a:r>
+                    </a:p>
+                  </a:txBody>
+                  <a:tcPr anchor="ctr">
+                    <a:solidFill>
+                      <a:srgbClr val="FFFFFF"/>
+                    </a:solidFill>
+                  </a:tcPr>
+                </a:tc>
+              </a:tr>
+              <a:tr h="320000">
+                <a:tc>
+                  <a:txBody>
+                    <a:bodyPr/>
+                    <a:lstStyle/>
+                    <a:p>
+                      <a:pPr algn="ctr">
+                        <a:defRPr sz="1100">
+                          <a:solidFill>
+                            <a:srgbClr val="333333"/>
+                          </a:solidFill>
+                        </a:defRPr>
+                      </a:pPr>
+                      <a:r>
+                        <a:t>penalty_2000</a:t>
+                      </a:r>
+                    </a:p>
+                  </a:txBody>
+                  <a:tcPr anchor="ctr">
+                    <a:solidFill>
+                      <a:srgbClr val="D6E8F7"/>
+                    </a:solidFill>
+                  </a:tcPr>
+                </a:tc>
+                <a:tc>
+                  <a:txBody>
+                    <a:bodyPr/>
+                    <a:lstStyle/>
+                    <a:p>
+                      <a:pPr algn="ctr">
+                        <a:defRPr sz="1100">
+                          <a:solidFill>
+                            <a:srgbClr val="333333"/>
+                          </a:solidFill>
+                        </a:defRPr>
+                      </a:pPr>
+                      <a:r>
+                        <a:t>11.43%</a:t>
+                      </a:r>
+                    </a:p>
+                  </a:txBody>
+                  <a:tcPr anchor="ctr">
+                    <a:solidFill>
+                      <a:srgbClr val="D6E8F7"/>
+                    </a:solidFill>
+                  </a:tcPr>
+                </a:tc>
+                <a:tc>
+                  <a:txBody>
+                    <a:bodyPr/>
+                    <a:lstStyle/>
+                    <a:p>
+                      <a:pPr algn="ctr">
+                        <a:defRPr sz="1100">
+                          <a:solidFill>
+                            <a:srgbClr val="333333"/>
+                          </a:solidFill>
+                        </a:defRPr>
+                      </a:pPr>
+                      <a:r>
+                        <a:t>1.51%</a:t>
+                      </a:r>
+                    </a:p>
+                  </a:txBody>
+                  <a:tcPr anchor="ctr">
+                    <a:solidFill>
+                      <a:srgbClr val="D6E8F7"/>
+                    </a:solidFill>
+                  </a:tcPr>
+                </a:tc>
+                <a:tc>
+                  <a:txBody>
+                    <a:bodyPr/>
+                    <a:lstStyle/>
+                    <a:p>
+                      <a:pPr algn="ctr">
+                        <a:defRPr sz="1100">
+                          <a:solidFill>
+                            <a:srgbClr val="333333"/>
+                          </a:solidFill>
+                        </a:defRPr>
+                      </a:pPr>
+                      <a:r>
+                        <a:t>-7.91</a:t>
+                      </a:r>
+                    </a:p>
+                  </a:txBody>
+                  <a:tcPr anchor="ctr">
+                    <a:solidFill>
+                      <a:srgbClr val="D6E8F7"/>
+                    </a:solidFill>
+                  </a:tcPr>
+                </a:tc>
+                <a:tc>
+                  <a:txBody>
+                    <a:bodyPr/>
+                    <a:lstStyle/>
+                    <a:p>
+                      <a:pPr algn="ctr">
+                        <a:defRPr sz="1100">
+                          <a:solidFill>
+                            <a:srgbClr val="333333"/>
+                          </a:solidFill>
+                        </a:defRPr>
+                      </a:pPr>
+                      <a:r>
+                        <a:t>125,040</a:t>
+                      </a:r>
+                    </a:p>
+                  </a:txBody>
+                  <a:tcPr anchor="ctr">
+                    <a:solidFill>
+                      <a:srgbClr val="D6E8F7"/>
+                    </a:solidFill>
+                  </a:tcPr>
+                </a:tc>
+                <a:tc>
+                  <a:txBody>
+                    <a:bodyPr/>
+                    <a:lstStyle/>
+                    <a:p>
+                      <a:pPr algn="ctr">
+                        <a:defRPr sz="1100">
+                          <a:solidFill>
+                            <a:srgbClr val="333333"/>
+                          </a:solidFill>
+                        </a:defRPr>
+                      </a:pPr>
+                      <a:r>
+                        <a:t>888,986</a:t>
+                      </a:r>
+                    </a:p>
+                  </a:txBody>
+                  <a:tcPr anchor="ctr">
+                    <a:solidFill>
+                      <a:srgbClr val="D6E8F7"/>
+                    </a:solidFill>
+                  </a:tcPr>
+                </a:tc>
+              </a:tr>
+              <a:tr h="320000">
+                <a:tc>
+                  <a:txBody>
+                    <a:bodyPr/>
+                    <a:lstStyle/>
+                    <a:p>
+                      <a:pPr algn="ctr">
+                        <a:defRPr sz="1100">
+                          <a:solidFill>
+                            <a:srgbClr val="333333"/>
+                          </a:solidFill>
+                        </a:defRPr>
+                      </a:pPr>
+                      <a:r>
+                        <a:t>penalty_5000</a:t>
+                      </a:r>
+                    </a:p>
+                  </a:txBody>
+                  <a:tcPr anchor="ctr">
+                    <a:solidFill>
+                      <a:srgbClr val="FFFFFF"/>
+                    </a:solidFill>
+                  </a:tcPr>
+                </a:tc>
+                <a:tc>
+                  <a:txBody>
+                    <a:bodyPr/>
+                    <a:lstStyle/>
+                    <a:p>
+                      <a:pPr algn="ctr">
+                        <a:defRPr sz="1100">
+                          <a:solidFill>
+                            <a:srgbClr val="333333"/>
+                          </a:solidFill>
+                        </a:defRPr>
+                      </a:pPr>
+                      <a:r>
+                        <a:t>11.91%</a:t>
+                      </a:r>
+                    </a:p>
+                  </a:txBody>
+                  <a:tcPr anchor="ctr">
+                    <a:solidFill>
+                      <a:srgbClr val="FFFFFF"/>
+                    </a:solidFill>
+                  </a:tcPr>
+                </a:tc>
+                <a:tc>
+                  <a:txBody>
+                    <a:bodyPr/>
+                    <a:lstStyle/>
+                    <a:p>
+                      <a:pPr algn="ctr">
+                        <a:defRPr sz="1100">
+                          <a:solidFill>
+                            <a:srgbClr val="333333"/>
+                          </a:solidFill>
+                        </a:defRPr>
+                      </a:pPr>
+                      <a:r>
+                        <a:t>1.49%</a:t>
+                      </a:r>
+                    </a:p>
+                  </a:txBody>
+                  <a:tcPr anchor="ctr">
+                    <a:solidFill>
+                      <a:srgbClr val="FFFFFF"/>
+                    </a:solidFill>
+                  </a:tcPr>
+                </a:tc>
+                <a:tc>
+                  <a:txBody>
+                    <a:bodyPr/>
+                    <a:lstStyle/>
+                    <a:p>
+                      <a:pPr algn="ctr">
+                        <a:defRPr sz="1100">
+                          <a:solidFill>
+                            <a:srgbClr val="333333"/>
+                          </a:solidFill>
+                        </a:defRPr>
+                      </a:pPr>
+                      <a:r>
+                        <a:t>-39.57</a:t>
+                      </a:r>
+                    </a:p>
+                  </a:txBody>
+                  <a:tcPr anchor="ctr">
+                    <a:solidFill>
+                      <a:srgbClr val="FFFFFF"/>
+                    </a:solidFill>
+                  </a:tcPr>
+                </a:tc>
+                <a:tc>
+                  <a:txBody>
+                    <a:bodyPr/>
+                    <a:lstStyle/>
+                    <a:p>
+                      <a:pPr algn="ctr">
+                        <a:defRPr sz="1100">
+                          <a:solidFill>
+                            <a:srgbClr val="333333"/>
+                          </a:solidFill>
+                        </a:defRPr>
+                      </a:pPr>
+                      <a:r>
+                        <a:t>121,351</a:t>
+                      </a:r>
+                    </a:p>
+                  </a:txBody>
+                  <a:tcPr anchor="ctr">
+                    <a:solidFill>
+                      <a:srgbClr val="FFFFFF"/>
+                    </a:solidFill>
+                  </a:tcPr>
+                </a:tc>
+                <a:tc>
+                  <a:txBody>
+                    <a:bodyPr/>
+                    <a:lstStyle/>
+                    <a:p>
+                      <a:pPr algn="ctr">
+                        <a:defRPr sz="1100">
+                          <a:solidFill>
+                            <a:srgbClr val="333333"/>
+                          </a:solidFill>
+                        </a:defRPr>
+                      </a:pPr>
+                      <a:r>
+                        <a:t>889,607</a:t>
+                      </a:r>
+                    </a:p>
+                  </a:txBody>
+                  <a:tcPr anchor="ctr">
+                    <a:solidFill>
+                      <a:srgbClr val="FFFFFF"/>
+                    </a:solidFill>
+                  </a:tcPr>
+                </a:tc>
+              </a:tr>
+              <a:tr h="320000">
+                <a:tc>
+                  <a:txBody>
+                    <a:bodyPr/>
+                    <a:lstStyle/>
+                    <a:p>
+                      <a:pPr algn="ctr">
+                        <a:defRPr sz="1100">
+                          <a:solidFill>
+                            <a:srgbClr val="333333"/>
+                          </a:solidFill>
+                        </a:defRPr>
+                      </a:pPr>
+                      <a:r>
+                        <a:t>penalty_10000</a:t>
+                      </a:r>
+                    </a:p>
+                  </a:txBody>
+                  <a:tcPr anchor="ctr">
+                    <a:solidFill>
+                      <a:srgbClr val="D6E8F7"/>
+                    </a:solidFill>
+                  </a:tcPr>
+                </a:tc>
+                <a:tc>
+                  <a:txBody>
+                    <a:bodyPr/>
+                    <a:lstStyle/>
+                    <a:p>
+                      <a:pPr algn="ctr">
+                        <a:defRPr sz="1100">
+                          <a:solidFill>
+                            <a:srgbClr val="333333"/>
+                          </a:solidFill>
+                        </a:defRPr>
+                      </a:pPr>
+                      <a:r>
+                        <a:t>12.80%</a:t>
+                      </a:r>
+                    </a:p>
+                  </a:txBody>
+                  <a:tcPr anchor="ctr">
+                    <a:solidFill>
+                      <a:srgbClr val="D6E8F7"/>
+                    </a:solidFill>
+                  </a:tcPr>
+                </a:tc>
+                <a:tc>
+                  <a:txBody>
+                    <a:bodyPr/>
+                    <a:lstStyle/>
+                    <a:p>
+                      <a:pPr algn="ctr">
+                        <a:defRPr sz="1100">
+                          <a:solidFill>
+                            <a:srgbClr val="333333"/>
+                          </a:solidFill>
+                        </a:defRPr>
+                      </a:pPr>
+                      <a:r>
+                        <a:t>1.49%</a:t>
+                      </a:r>
+                    </a:p>
+                  </a:txBody>
+                  <a:tcPr anchor="ctr">
+                    <a:solidFill>
+                      <a:srgbClr val="D6E8F7"/>
+                    </a:solidFill>
+                  </a:tcPr>
+                </a:tc>
+                <a:tc>
+                  <a:txBody>
+                    <a:bodyPr/>
+                    <a:lstStyle/>
+                    <a:p>
+                      <a:pPr algn="ctr">
+                        <a:defRPr sz="1100">
+                          <a:solidFill>
+                            <a:srgbClr val="333333"/>
+                          </a:solidFill>
+                        </a:defRPr>
+                      </a:pPr>
+                      <a:r>
+                        <a:t>-88.35</a:t>
+                      </a:r>
+                    </a:p>
+                  </a:txBody>
+                  <a:tcPr anchor="ctr">
+                    <a:solidFill>
+                      <a:srgbClr val="D6E8F7"/>
+                    </a:solidFill>
+                  </a:tcPr>
+                </a:tc>
+                <a:tc>
+                  <a:txBody>
+                    <a:bodyPr/>
+                    <a:lstStyle/>
+                    <a:p>
+                      <a:pPr algn="ctr">
+                        <a:defRPr sz="1100">
+                          <a:solidFill>
+                            <a:srgbClr val="333333"/>
+                          </a:solidFill>
+                        </a:defRPr>
+                      </a:pPr>
+                      <a:r>
+                        <a:t>123,328</a:t>
+                      </a:r>
+                    </a:p>
+                  </a:txBody>
+                  <a:tcPr anchor="ctr">
+                    <a:solidFill>
+                      <a:srgbClr val="D6E8F7"/>
+                    </a:solidFill>
+                  </a:tcPr>
+                </a:tc>
+                <a:tc>
+                  <a:txBody>
+                    <a:bodyPr/>
+                    <a:lstStyle/>
+                    <a:p>
+                      <a:pPr algn="ctr">
+                        <a:defRPr sz="1100">
+                          <a:solidFill>
+                            <a:srgbClr val="333333"/>
+                          </a:solidFill>
+                        </a:defRPr>
+                      </a:pPr>
+                      <a:r>
+                        <a:t>888,693</a:t>
+                      </a:r>
+                    </a:p>
+                  </a:txBody>
+                  <a:tcPr anchor="ctr">
+                    <a:solidFill>
+                      <a:srgbClr val="D6E8F7"/>
+                    </a:solidFill>
+                  </a:tcPr>
+                </a:tc>
+              </a:tr>
+            </a:tbl>
+          </a:graphicData>
+        </a:graphic>
+      </p:graphicFrame>
+      <p:sp>
+        <p:nvSpPr>
+          <p:cNvPr id="5" name="TextBox 4"/>
+          <p:cNvSpPr txBox="1"/>
+          <p:nvPr/>
+        </p:nvSpPr>
+        <p:spPr>
+          <a:xfrm>
+            <a:off x="548640" y="4343400"/>
+            <a:ext cx="11064240" cy="2011680"/>
+          </a:xfrm>
+          <a:prstGeom prst="rect">
+            <a:avLst/>
+          </a:prstGeom>
+          <a:noFill/>
+        </p:spPr>
+        <p:txBody>
+          <a:bodyPr wrap="square">
+            <a:spAutoFit/>
+          </a:bodyPr>
+          <a:lstStyle/>
+          <a:p>
+            <a:pPr>
+              <a:spcAft>
+                <a:spcPts val="500"/>
+              </a:spcAft>
+            </a:pPr>
+            <a:r>
+              <a:rPr sz="1500" b="1">
+                <a:solidFill>
+                  <a:srgbClr val="C0392B"/>
+                </a:solidFill>
+              </a:rPr>
+              <a:t>Higher caps widen tails and increase negative-LMP frequency.</a:t>
+            </a:r>
+          </a:p>
+          <a:p>
+            <a:pPr>
+              <a:spcAft>
+                <a:spcPts val="500"/>
+              </a:spcAft>
+            </a:pPr>
+            <a:r>
+              <a:rPr sz="1500" b="0">
+                <a:solidFill>
+                  <a:srgbClr val="333333"/>
+                </a:solidFill>
+              </a:rPr>
+              <a:t>Floor-hit fraction stays ~1.5% across cases (persistent clipping).</a:t>
+            </a:r>
+          </a:p>
+          <a:p>
+            <a:pPr>
+              <a:spcAft>
+                <a:spcPts val="500"/>
+              </a:spcAft>
+            </a:pPr>
+            <a:r>
+              <a:rPr sz="1500" b="0">
+                <a:solidFill>
+                  <a:srgbClr val="333333"/>
+                </a:solidFill>
+              </a:rPr>
+              <a:t>Weighted LMP trends downward sharply as cap increases.</a:t>
+            </a:r>
+          </a:p>
+          <a:p>
+            <a:pPr>
+              <a:spcAft>
+                <a:spcPts val="500"/>
+              </a:spcAft>
+            </a:pPr>
+            <a:r>
+              <a:rPr sz="1500" b="0">
+                <a:solidFill>
+                  <a:srgbClr val="333333"/>
+                </a:solidFill>
+              </a:rPr>
+              <a:t>Overgeneration remains high and nearly flat (~888-890 GWh): cap tuning alone is not a structural fix.</a:t>
+            </a:r>
+          </a:p>
+        </p:txBody>
+      </p:sp>
+    </p:spTree>
+  </p:cSld>
+  <p:clrMapOvr>
+    <a:masterClrMapping/>
+  </p:clrMapOvr>
+</p:sld>
+</file>
+
+<file path=ppt/slides/slide15.xml><?xml version="1.0" encoding="utf-8"?>
+<p:sld xmlns:a="http://schemas.openxmlformats.org/drawingml/2006/main" xmlns:p="http://schemas.openxmlformats.org/presentationml/2006/main" xmlns:r="http://schemas.openxmlformats.org/officeDocument/2006/relationships">
+  <p:cSld>
+    <p:bg>
+      <p:bgPr>
+        <a:solidFill>
+          <a:srgbClr val="FFFFFF"/>
+        </a:solidFill>
+        <a:effectLst/>
+      </p:bgPr>
+    </p:bg>
+    <p:spTree>
+      <p:nvGrpSpPr>
+        <p:cNvPr id="1" name=""/>
+        <p:cNvGrpSpPr/>
+        <p:nvPr/>
+      </p:nvGrpSpPr>
+      <p:grpSpPr/>
+      <p:sp>
+        <p:nvSpPr>
+          <p:cNvPr id="2" name="Rectangle 1"/>
+          <p:cNvSpPr/>
+          <p:nvPr/>
+        </p:nvSpPr>
+        <p:spPr>
+          <a:xfrm>
+            <a:off x="0" y="0"/>
+            <a:ext cx="12191695" cy="1097280"/>
+          </a:xfrm>
+          <a:prstGeom prst="rect">
+            <a:avLst/>
+          </a:prstGeom>
+          <a:solidFill>
+            <a:srgbClr val="1B3A5C"/>
+          </a:solidFill>
+          <a:ln>
+            <a:noFill/>
+          </a:ln>
+        </p:spPr>
+        <p:style>
+          <a:lnRef idx="1">
+            <a:schemeClr val="accent1"/>
+          </a:lnRef>
+          <a:fillRef idx="3">
+            <a:schemeClr val="accent1"/>
+          </a:fillRef>
+          <a:effectRef idx="2">
+            <a:schemeClr val="accent1"/>
+          </a:effectRef>
+          <a:fontRef idx="minor">
+            <a:schemeClr val="lt1"/>
+          </a:fontRef>
+        </p:style>
+        <p:txBody>
+          <a:bodyPr rtlCol="0" anchor="ctr" wrap="square" lIns="548640"/>
+          <a:lstStyle/>
+          <a:p>
+            <a:pPr algn="l">
+              <a:defRPr sz="3000" b="1">
+                <a:solidFill>
+                  <a:srgbClr val="FFFFFF"/>
+                </a:solidFill>
+              </a:defRPr>
+            </a:pPr>
+            <a:r>
+              <a:t>Corrected Paper Curtailment Mechanism vs Our Model</a:t>
+            </a:r>
+          </a:p>
+        </p:txBody>
+      </p:sp>
+      <p:sp>
+        <p:nvSpPr>
+          <p:cNvPr id="3" name="Rectangle 2"/>
+          <p:cNvSpPr/>
+          <p:nvPr/>
+        </p:nvSpPr>
+        <p:spPr>
+          <a:xfrm>
+            <a:off x="0" y="1097280"/>
+            <a:ext cx="12191695" cy="411480"/>
+          </a:xfrm>
+          <a:prstGeom prst="rect">
+            <a:avLst/>
+          </a:prstGeom>
+          <a:solidFill>
+            <a:srgbClr val="2C5F8A"/>
+          </a:solidFill>
+          <a:ln>
+            <a:noFill/>
+          </a:ln>
+        </p:spPr>
+        <p:style>
+          <a:lnRef idx="1">
+            <a:schemeClr val="accent1"/>
+          </a:lnRef>
+          <a:fillRef idx="3">
+            <a:schemeClr val="accent1"/>
+          </a:fillRef>
+          <a:effectRef idx="2">
+            <a:schemeClr val="accent1"/>
+          </a:effectRef>
+          <a:fontRef idx="minor">
+            <a:schemeClr val="lt1"/>
+          </a:fontRef>
+        </p:style>
+        <p:txBody>
+          <a:bodyPr rtlCol="0" anchor="ctr" lIns="548640"/>
+          <a:lstStyle/>
+          <a:p>
+            <a:pPr algn="l">
+              <a:defRPr sz="1500" i="1">
+                <a:solidFill>
+                  <a:srgbClr val="CCDDEE"/>
+                </a:solidFill>
+              </a:defRPr>
+            </a:pPr>
+            <a:r>
+              <a:t>Paper: bounded net-load slack; Ours: threshold-driven market proxy behavior</a:t>
+            </a:r>
+          </a:p>
+        </p:txBody>
+      </p:sp>
+      <p:sp>
+        <p:nvSpPr>
+          <p:cNvPr id="4" name="TextBox 3"/>
+          <p:cNvSpPr txBox="1"/>
+          <p:nvPr/>
+        </p:nvSpPr>
+        <p:spPr>
+          <a:xfrm>
+            <a:off x="548640" y="1874520"/>
+            <a:ext cx="5394960" cy="4480560"/>
+          </a:xfrm>
+          <a:prstGeom prst="rect">
+            <a:avLst/>
+          </a:prstGeom>
+          <a:noFill/>
+        </p:spPr>
+        <p:txBody>
+          <a:bodyPr wrap="square">
+            <a:spAutoFit/>
+          </a:bodyPr>
+          <a:lstStyle/>
+          <a:p>
+            <a:pPr>
+              <a:spcAft>
+                <a:spcPts val="500"/>
+              </a:spcAft>
+            </a:pPr>
+            <a:r>
+              <a:rPr sz="1400" b="1">
+                <a:solidFill>
+                  <a:srgbClr val="333333"/>
+                </a:solidFill>
+              </a:rPr>
+              <a:t>Paper Pyomo (actual implementation):</a:t>
+            </a:r>
+          </a:p>
+          <a:p>
+            <a:pPr lvl="1">
+              <a:spcAft>
+                <a:spcPts val="500"/>
+              </a:spcAft>
+            </a:pPr>
+            <a:r>
+              <a:rPr sz="1400" b="0">
+                <a:solidFill>
+                  <a:srgbClr val="333333"/>
+                </a:solidFill>
+              </a:rPr>
+              <a:t>Wind/solar subtracted from load first (net-load).</a:t>
+            </a:r>
+          </a:p>
+          <a:p>
+            <a:pPr lvl="1">
+              <a:spcAft>
+                <a:spcPts val="500"/>
+              </a:spcAft>
+            </a:pPr>
+            <a:r>
+              <a:rPr sz="1400" b="0">
+                <a:solidFill>
+                  <a:srgbClr val="333333"/>
+                </a:solidFill>
+              </a:rPr>
+              <a:t>rnwcur_b_t &gt;= 0 and only active when net load &lt; 0.</a:t>
+            </a:r>
+          </a:p>
+          <a:p>
+            <a:pPr lvl="1">
+              <a:spcAft>
+                <a:spcPts val="500"/>
+              </a:spcAft>
+            </a:pPr>
+            <a:r>
+              <a:rPr sz="1400" b="0">
+                <a:solidFill>
+                  <a:srgbClr val="333333"/>
+                </a:solidFill>
+              </a:rPr>
+              <a:t>Bounded by magnitude of negative net load.</a:t>
+            </a:r>
+          </a:p>
+          <a:p>
+            <a:pPr lvl="1">
+              <a:spcAft>
+                <a:spcPts val="500"/>
+              </a:spcAft>
+            </a:pPr>
+            <a:r>
+              <a:rPr sz="1400" b="0">
+                <a:solidFill>
+                  <a:srgbClr val="333333"/>
+                </a:solidFill>
+              </a:rPr>
+              <a:t>Appears in nodal balance RHS as balancing relief.</a:t>
+            </a:r>
+          </a:p>
+          <a:p>
+            <a:pPr lvl="1">
+              <a:spcAft>
+                <a:spcPts val="500"/>
+              </a:spcAft>
+            </a:pPr>
+            <a:r>
+              <a:rPr sz="1400" b="1">
+                <a:solidFill>
+                  <a:srgbClr val="333333"/>
+                </a:solidFill>
+              </a:rPr>
+              <a:t>No direct curtailment objective-cost term.</a:t>
+            </a:r>
+          </a:p>
+        </p:txBody>
+      </p:sp>
+      <p:sp>
+        <p:nvSpPr>
+          <p:cNvPr id="5" name="TextBox 4"/>
+          <p:cNvSpPr txBox="1"/>
+          <p:nvPr/>
+        </p:nvSpPr>
+        <p:spPr>
+          <a:xfrm>
+            <a:off x="6217920" y="1874520"/>
+            <a:ext cx="5486400" cy="4480560"/>
+          </a:xfrm>
+          <a:prstGeom prst="rect">
+            <a:avLst/>
+          </a:prstGeom>
+          <a:noFill/>
+        </p:spPr>
+        <p:txBody>
+          <a:bodyPr wrap="square">
+            <a:spAutoFit/>
+          </a:bodyPr>
+          <a:lstStyle/>
+          <a:p>
+            <a:pPr>
+              <a:spcAft>
+                <a:spcPts val="500"/>
+              </a:spcAft>
+            </a:pPr>
+            <a:r>
+              <a:rPr sz="1400" b="1">
+                <a:solidFill>
+                  <a:srgbClr val="333333"/>
+                </a:solidFill>
+              </a:rPr>
+              <a:t>Our Prescient benchmark run:</a:t>
+            </a:r>
+          </a:p>
+          <a:p>
+            <a:pPr lvl="1">
+              <a:spcAft>
+                <a:spcPts val="500"/>
+              </a:spcAft>
+            </a:pPr>
+            <a:r>
+              <a:rPr sz="1400" b="0">
+                <a:solidFill>
+                  <a:srgbClr val="333333"/>
+                </a:solidFill>
+              </a:rPr>
+              <a:t>Explicit renewable participation in clearing.</a:t>
+            </a:r>
+          </a:p>
+          <a:p>
+            <a:pPr lvl="1">
+              <a:spcAft>
+                <a:spcPts val="500"/>
+              </a:spcAft>
+            </a:pPr>
+            <a:r>
+              <a:rPr sz="1400" b="0">
+                <a:solidFill>
+                  <a:srgbClr val="333333"/>
+                </a:solidFill>
+              </a:rPr>
+              <a:t>Curtailment influenced by penalty/threshold economics.</a:t>
+            </a:r>
+          </a:p>
+          <a:p>
+            <a:pPr lvl="1">
+              <a:spcAft>
+                <a:spcPts val="500"/>
+              </a:spcAft>
+            </a:pPr>
+            <a:r>
+              <a:rPr sz="1400" b="0">
+                <a:solidFill>
+                  <a:srgbClr val="333333"/>
+                </a:solidFill>
+              </a:rPr>
+              <a:t>Cap tuning changes tail behavior strongly.</a:t>
+            </a:r>
+          </a:p>
+          <a:p>
+            <a:pPr lvl="1">
+              <a:spcAft>
+                <a:spcPts val="500"/>
+              </a:spcAft>
+            </a:pPr>
+            <a:r>
+              <a:rPr sz="1400" b="0">
+                <a:solidFill>
+                  <a:srgbClr val="333333"/>
+                </a:solidFill>
+              </a:rPr>
+              <a:t>But surplus/overgeneration remains structurally high.</a:t>
+            </a:r>
+          </a:p>
+          <a:p>
+            <a:pPr lvl="1">
+              <a:spcAft>
+                <a:spcPts val="500"/>
+              </a:spcAft>
+            </a:pPr>
+            <a:r>
+              <a:rPr sz="1400" b="1">
+                <a:solidFill>
+                  <a:srgbClr val="C0392B"/>
+                </a:solidFill>
+              </a:rPr>
+              <a:t>Implication: structural alignment still needed for paper-like LMP behavior.</a:t>
             </a:r>
           </a:p>
         </p:txBody>

</xml_diff>